<commit_message>
Fix fly-in answer animation trigger
</commit_message>
<xml_diff>
--- a/mypaper_answers.pptx
+++ b/mypaper_answers.pptx
@@ -3458,7 +3458,7 @@
                   <p:par>
                     <p:cTn id="3" fill="hold">
                       <p:stCondLst>
-                        <p:cond delay="0"/>
+                        <p:cond delay="indefinite"/>
                       </p:stCondLst>
                       <p:childTnLst>
                         <p:par>
@@ -3481,7 +3481,7 @@
                                   <p:strVal val="visible"/>
                                 </p:to>
                               </p:set>
-                              <p:animEffect transition="in" filter="fly" prLst="dir=l">
+                              <p:animEffect transition="in" filter="fly(l)" prLst="dir=l">
                                 <p:cBhvr>
                                   <p:cTn id="6" dur="500"/>
                                   <p:tgtEl>
@@ -3498,7 +3498,7 @@
                   <p:par>
                     <p:cTn id="7" fill="hold">
                       <p:stCondLst>
-                        <p:cond delay="0"/>
+                        <p:cond delay="indefinite"/>
                       </p:stCondLst>
                       <p:childTnLst>
                         <p:par>
@@ -3521,7 +3521,7 @@
                                   <p:strVal val="visible"/>
                                 </p:to>
                               </p:set>
-                              <p:animEffect transition="in" filter="fly" prLst="dir=l">
+                              <p:animEffect transition="in" filter="fly(l)" prLst="dir=l">
                                 <p:cBhvr>
                                   <p:cTn id="10" dur="500"/>
                                   <p:tgtEl>
@@ -3543,8 +3543,8 @@
       </p:par>
     </p:tnLst>
     <p:bldLst>
-      <p:bldP spid="4" grpId="0"/>
-      <p:bldP spid="6" grpId="0"/>
+      <p:bldP spid="4" grpId="0" build="allAtOnce"/>
+      <p:bldP spid="6" grpId="0" build="allAtOnce"/>
     </p:bldLst>
   </p:timing>
 </p:sld>
@@ -3863,7 +3863,7 @@
                   <p:par>
                     <p:cTn id="3" fill="hold">
                       <p:stCondLst>
-                        <p:cond delay="0"/>
+                        <p:cond delay="indefinite"/>
                       </p:stCondLst>
                       <p:childTnLst>
                         <p:par>
@@ -3886,7 +3886,7 @@
                                   <p:strVal val="visible"/>
                                 </p:to>
                               </p:set>
-                              <p:animEffect transition="in" filter="fly" prLst="dir=l">
+                              <p:animEffect transition="in" filter="fly(l)" prLst="dir=l">
                                 <p:cBhvr>
                                   <p:cTn id="6" dur="500"/>
                                   <p:tgtEl>
@@ -3908,7 +3908,7 @@
       </p:par>
     </p:tnLst>
     <p:bldLst>
-      <p:bldP spid="3" grpId="0"/>
+      <p:bldP spid="3" grpId="0" build="allAtOnce"/>
     </p:bldLst>
   </p:timing>
 </p:sld>
@@ -4170,7 +4170,7 @@
                   <p:par>
                     <p:cTn id="3" fill="hold">
                       <p:stCondLst>
-                        <p:cond delay="0"/>
+                        <p:cond delay="indefinite"/>
                       </p:stCondLst>
                       <p:childTnLst>
                         <p:par>
@@ -4193,7 +4193,7 @@
                                   <p:strVal val="visible"/>
                                 </p:to>
                               </p:set>
-                              <p:animEffect transition="in" filter="fly" prLst="dir=l">
+                              <p:animEffect transition="in" filter="fly(l)" prLst="dir=l">
                                 <p:cBhvr>
                                   <p:cTn id="6" dur="500"/>
                                   <p:tgtEl>
@@ -4215,7 +4215,7 @@
       </p:par>
     </p:tnLst>
     <p:bldLst>
-      <p:bldP spid="3" grpId="0"/>
+      <p:bldP spid="3" grpId="0" build="allAtOnce"/>
     </p:bldLst>
   </p:timing>
 </p:sld>
@@ -4525,7 +4525,7 @@
                   <p:par>
                     <p:cTn id="3" fill="hold">
                       <p:stCondLst>
-                        <p:cond delay="0"/>
+                        <p:cond delay="indefinite"/>
                       </p:stCondLst>
                       <p:childTnLst>
                         <p:par>
@@ -4548,7 +4548,7 @@
                                   <p:strVal val="visible"/>
                                 </p:to>
                               </p:set>
-                              <p:animEffect transition="in" filter="fly" prLst="dir=l">
+                              <p:animEffect transition="in" filter="fly(l)" prLst="dir=l">
                                 <p:cBhvr>
                                   <p:cTn id="6" dur="500"/>
                                   <p:tgtEl>
@@ -4570,7 +4570,7 @@
       </p:par>
     </p:tnLst>
     <p:bldLst>
-      <p:bldP spid="3" grpId="0"/>
+      <p:bldP spid="3" grpId="0" build="allAtOnce"/>
     </p:bldLst>
   </p:timing>
 </p:sld>
@@ -4879,7 +4879,7 @@
                   <p:par>
                     <p:cTn id="3" fill="hold">
                       <p:stCondLst>
-                        <p:cond delay="0"/>
+                        <p:cond delay="indefinite"/>
                       </p:stCondLst>
                       <p:childTnLst>
                         <p:par>
@@ -4902,7 +4902,7 @@
                                   <p:strVal val="visible"/>
                                 </p:to>
                               </p:set>
-                              <p:animEffect transition="in" filter="fly" prLst="dir=l">
+                              <p:animEffect transition="in" filter="fly(l)" prLst="dir=l">
                                 <p:cBhvr>
                                   <p:cTn id="6" dur="500"/>
                                   <p:tgtEl>
@@ -4919,7 +4919,7 @@
                   <p:par>
                     <p:cTn id="7" fill="hold">
                       <p:stCondLst>
-                        <p:cond delay="0"/>
+                        <p:cond delay="indefinite"/>
                       </p:stCondLst>
                       <p:childTnLst>
                         <p:par>
@@ -4942,7 +4942,7 @@
                                   <p:strVal val="visible"/>
                                 </p:to>
                               </p:set>
-                              <p:animEffect transition="in" filter="fly" prLst="dir=l">
+                              <p:animEffect transition="in" filter="fly(l)" prLst="dir=l">
                                 <p:cBhvr>
                                   <p:cTn id="10" dur="500"/>
                                   <p:tgtEl>
@@ -4964,8 +4964,8 @@
       </p:par>
     </p:tnLst>
     <p:bldLst>
-      <p:bldP spid="4" grpId="0"/>
-      <p:bldP spid="6" grpId="0"/>
+      <p:bldP spid="4" grpId="0" build="allAtOnce"/>
+      <p:bldP spid="6" grpId="0" build="allAtOnce"/>
     </p:bldLst>
   </p:timing>
 </p:sld>
@@ -5276,7 +5276,7 @@
                   <p:par>
                     <p:cTn id="3" fill="hold">
                       <p:stCondLst>
-                        <p:cond delay="0"/>
+                        <p:cond delay="indefinite"/>
                       </p:stCondLst>
                       <p:childTnLst>
                         <p:par>
@@ -5299,7 +5299,7 @@
                                   <p:strVal val="visible"/>
                                 </p:to>
                               </p:set>
-                              <p:animEffect transition="in" filter="fly" prLst="dir=l">
+                              <p:animEffect transition="in" filter="fly(l)" prLst="dir=l">
                                 <p:cBhvr>
                                   <p:cTn id="6" dur="500"/>
                                   <p:tgtEl>
@@ -5316,7 +5316,7 @@
                   <p:par>
                     <p:cTn id="7" fill="hold">
                       <p:stCondLst>
-                        <p:cond delay="0"/>
+                        <p:cond delay="indefinite"/>
                       </p:stCondLst>
                       <p:childTnLst>
                         <p:par>
@@ -5339,7 +5339,7 @@
                                   <p:strVal val="visible"/>
                                 </p:to>
                               </p:set>
-                              <p:animEffect transition="in" filter="fly" prLst="dir=l">
+                              <p:animEffect transition="in" filter="fly(l)" prLst="dir=l">
                                 <p:cBhvr>
                                   <p:cTn id="10" dur="500"/>
                                   <p:tgtEl>
@@ -5361,8 +5361,8 @@
       </p:par>
     </p:tnLst>
     <p:bldLst>
-      <p:bldP spid="4" grpId="0"/>
-      <p:bldP spid="6" grpId="0"/>
+      <p:bldP spid="4" grpId="0" build="allAtOnce"/>
+      <p:bldP spid="6" grpId="0" build="allAtOnce"/>
     </p:bldLst>
   </p:timing>
 </p:sld>
@@ -5671,7 +5671,7 @@
                   <p:par>
                     <p:cTn id="3" fill="hold">
                       <p:stCondLst>
-                        <p:cond delay="0"/>
+                        <p:cond delay="indefinite"/>
                       </p:stCondLst>
                       <p:childTnLst>
                         <p:par>
@@ -5694,7 +5694,7 @@
                                   <p:strVal val="visible"/>
                                 </p:to>
                               </p:set>
-                              <p:animEffect transition="in" filter="fly" prLst="dir=l">
+                              <p:animEffect transition="in" filter="fly(l)" prLst="dir=l">
                                 <p:cBhvr>
                                   <p:cTn id="6" dur="500"/>
                                   <p:tgtEl>
@@ -5711,7 +5711,7 @@
                   <p:par>
                     <p:cTn id="7" fill="hold">
                       <p:stCondLst>
-                        <p:cond delay="0"/>
+                        <p:cond delay="indefinite"/>
                       </p:stCondLst>
                       <p:childTnLst>
                         <p:par>
@@ -5734,7 +5734,7 @@
                                   <p:strVal val="visible"/>
                                 </p:to>
                               </p:set>
-                              <p:animEffect transition="in" filter="fly" prLst="dir=l">
+                              <p:animEffect transition="in" filter="fly(l)" prLst="dir=l">
                                 <p:cBhvr>
                                   <p:cTn id="10" dur="500"/>
                                   <p:tgtEl>
@@ -5756,8 +5756,8 @@
       </p:par>
     </p:tnLst>
     <p:bldLst>
-      <p:bldP spid="4" grpId="0"/>
-      <p:bldP spid="6" grpId="0"/>
+      <p:bldP spid="4" grpId="0" build="allAtOnce"/>
+      <p:bldP spid="6" grpId="0" build="allAtOnce"/>
     </p:bldLst>
   </p:timing>
 </p:sld>
@@ -6067,7 +6067,7 @@
                   <p:par>
                     <p:cTn id="3" fill="hold">
                       <p:stCondLst>
-                        <p:cond delay="0"/>
+                        <p:cond delay="indefinite"/>
                       </p:stCondLst>
                       <p:childTnLst>
                         <p:par>
@@ -6090,7 +6090,7 @@
                                   <p:strVal val="visible"/>
                                 </p:to>
                               </p:set>
-                              <p:animEffect transition="in" filter="fly" prLst="dir=l">
+                              <p:animEffect transition="in" filter="fly(l)" prLst="dir=l">
                                 <p:cBhvr>
                                   <p:cTn id="6" dur="500"/>
                                   <p:tgtEl>
@@ -6107,7 +6107,7 @@
                   <p:par>
                     <p:cTn id="7" fill="hold">
                       <p:stCondLst>
-                        <p:cond delay="0"/>
+                        <p:cond delay="indefinite"/>
                       </p:stCondLst>
                       <p:childTnLst>
                         <p:par>
@@ -6130,7 +6130,7 @@
                                   <p:strVal val="visible"/>
                                 </p:to>
                               </p:set>
-                              <p:animEffect transition="in" filter="fly" prLst="dir=l">
+                              <p:animEffect transition="in" filter="fly(l)" prLst="dir=l">
                                 <p:cBhvr>
                                   <p:cTn id="10" dur="500"/>
                                   <p:tgtEl>
@@ -6152,8 +6152,8 @@
       </p:par>
     </p:tnLst>
     <p:bldLst>
-      <p:bldP spid="4" grpId="0"/>
-      <p:bldP spid="6" grpId="0"/>
+      <p:bldP spid="4" grpId="0" build="allAtOnce"/>
+      <p:bldP spid="6" grpId="0" build="allAtOnce"/>
     </p:bldLst>
   </p:timing>
 </p:sld>
@@ -6464,7 +6464,7 @@
                   <p:par>
                     <p:cTn id="3" fill="hold">
                       <p:stCondLst>
-                        <p:cond delay="0"/>
+                        <p:cond delay="indefinite"/>
                       </p:stCondLst>
                       <p:childTnLst>
                         <p:par>
@@ -6487,7 +6487,7 @@
                                   <p:strVal val="visible"/>
                                 </p:to>
                               </p:set>
-                              <p:animEffect transition="in" filter="fly" prLst="dir=l">
+                              <p:animEffect transition="in" filter="fly(l)" prLst="dir=l">
                                 <p:cBhvr>
                                   <p:cTn id="6" dur="500"/>
                                   <p:tgtEl>
@@ -6504,7 +6504,7 @@
                   <p:par>
                     <p:cTn id="7" fill="hold">
                       <p:stCondLst>
-                        <p:cond delay="0"/>
+                        <p:cond delay="indefinite"/>
                       </p:stCondLst>
                       <p:childTnLst>
                         <p:par>
@@ -6527,7 +6527,7 @@
                                   <p:strVal val="visible"/>
                                 </p:to>
                               </p:set>
-                              <p:animEffect transition="in" filter="fly" prLst="dir=l">
+                              <p:animEffect transition="in" filter="fly(l)" prLst="dir=l">
                                 <p:cBhvr>
                                   <p:cTn id="10" dur="500"/>
                                   <p:tgtEl>
@@ -6549,8 +6549,8 @@
       </p:par>
     </p:tnLst>
     <p:bldLst>
-      <p:bldP spid="4" grpId="0"/>
-      <p:bldP spid="6" grpId="0"/>
+      <p:bldP spid="4" grpId="0" build="allAtOnce"/>
+      <p:bldP spid="6" grpId="0" build="allAtOnce"/>
     </p:bldLst>
   </p:timing>
 </p:sld>
@@ -6858,7 +6858,7 @@
                   <p:par>
                     <p:cTn id="3" fill="hold">
                       <p:stCondLst>
-                        <p:cond delay="0"/>
+                        <p:cond delay="indefinite"/>
                       </p:stCondLst>
                       <p:childTnLst>
                         <p:par>
@@ -6881,7 +6881,7 @@
                                   <p:strVal val="visible"/>
                                 </p:to>
                               </p:set>
-                              <p:animEffect transition="in" filter="fly" prLst="dir=l">
+                              <p:animEffect transition="in" filter="fly(l)" prLst="dir=l">
                                 <p:cBhvr>
                                   <p:cTn id="6" dur="500"/>
                                   <p:tgtEl>
@@ -6898,7 +6898,7 @@
                   <p:par>
                     <p:cTn id="7" fill="hold">
                       <p:stCondLst>
-                        <p:cond delay="0"/>
+                        <p:cond delay="indefinite"/>
                       </p:stCondLst>
                       <p:childTnLst>
                         <p:par>
@@ -6921,7 +6921,7 @@
                                   <p:strVal val="visible"/>
                                 </p:to>
                               </p:set>
-                              <p:animEffect transition="in" filter="fly" prLst="dir=l">
+                              <p:animEffect transition="in" filter="fly(l)" prLst="dir=l">
                                 <p:cBhvr>
                                   <p:cTn id="10" dur="500"/>
                                   <p:tgtEl>
@@ -6943,8 +6943,8 @@
       </p:par>
     </p:tnLst>
     <p:bldLst>
-      <p:bldP spid="4" grpId="0"/>
-      <p:bldP spid="6" grpId="0"/>
+      <p:bldP spid="4" grpId="0" build="allAtOnce"/>
+      <p:bldP spid="6" grpId="0" build="allAtOnce"/>
     </p:bldLst>
   </p:timing>
 </p:sld>
@@ -7256,7 +7256,7 @@
                   <p:par>
                     <p:cTn id="3" fill="hold">
                       <p:stCondLst>
-                        <p:cond delay="0"/>
+                        <p:cond delay="indefinite"/>
                       </p:stCondLst>
                       <p:childTnLst>
                         <p:par>
@@ -7279,7 +7279,7 @@
                                   <p:strVal val="visible"/>
                                 </p:to>
                               </p:set>
-                              <p:animEffect transition="in" filter="fly" prLst="dir=l">
+                              <p:animEffect transition="in" filter="fly(l)" prLst="dir=l">
                                 <p:cBhvr>
                                   <p:cTn id="6" dur="500"/>
                                   <p:tgtEl>
@@ -7296,7 +7296,7 @@
                   <p:par>
                     <p:cTn id="7" fill="hold">
                       <p:stCondLst>
-                        <p:cond delay="0"/>
+                        <p:cond delay="indefinite"/>
                       </p:stCondLst>
                       <p:childTnLst>
                         <p:par>
@@ -7319,7 +7319,7 @@
                                   <p:strVal val="visible"/>
                                 </p:to>
                               </p:set>
-                              <p:animEffect transition="in" filter="fly" prLst="dir=l">
+                              <p:animEffect transition="in" filter="fly(l)" prLst="dir=l">
                                 <p:cBhvr>
                                   <p:cTn id="10" dur="500"/>
                                   <p:tgtEl>
@@ -7341,8 +7341,8 @@
       </p:par>
     </p:tnLst>
     <p:bldLst>
-      <p:bldP spid="4" grpId="0"/>
-      <p:bldP spid="6" grpId="0"/>
+      <p:bldP spid="4" grpId="0" build="allAtOnce"/>
+      <p:bldP spid="6" grpId="0" build="allAtOnce"/>
     </p:bldLst>
   </p:timing>
 </p:sld>
@@ -7656,7 +7656,7 @@
                   <p:par>
                     <p:cTn id="3" fill="hold">
                       <p:stCondLst>
-                        <p:cond delay="0"/>
+                        <p:cond delay="indefinite"/>
                       </p:stCondLst>
                       <p:childTnLst>
                         <p:par>
@@ -7679,7 +7679,7 @@
                                   <p:strVal val="visible"/>
                                 </p:to>
                               </p:set>
-                              <p:animEffect transition="in" filter="fly" prLst="dir=l">
+                              <p:animEffect transition="in" filter="fly(l)" prLst="dir=l">
                                 <p:cBhvr>
                                   <p:cTn id="6" dur="500"/>
                                   <p:tgtEl>
@@ -7696,7 +7696,7 @@
                   <p:par>
                     <p:cTn id="7" fill="hold">
                       <p:stCondLst>
-                        <p:cond delay="0"/>
+                        <p:cond delay="indefinite"/>
                       </p:stCondLst>
                       <p:childTnLst>
                         <p:par>
@@ -7719,7 +7719,7 @@
                                   <p:strVal val="visible"/>
                                 </p:to>
                               </p:set>
-                              <p:animEffect transition="in" filter="fly" prLst="dir=l">
+                              <p:animEffect transition="in" filter="fly(l)" prLst="dir=l">
                                 <p:cBhvr>
                                   <p:cTn id="10" dur="500"/>
                                   <p:tgtEl>
@@ -7741,8 +7741,8 @@
       </p:par>
     </p:tnLst>
     <p:bldLst>
-      <p:bldP spid="4" grpId="0"/>
-      <p:bldP spid="6" grpId="0"/>
+      <p:bldP spid="4" grpId="0" build="allAtOnce"/>
+      <p:bldP spid="6" grpId="0" build="allAtOnce"/>
     </p:bldLst>
   </p:timing>
 </p:sld>
@@ -8052,7 +8052,7 @@
                   <p:par>
                     <p:cTn id="3" fill="hold">
                       <p:stCondLst>
-                        <p:cond delay="0"/>
+                        <p:cond delay="indefinite"/>
                       </p:stCondLst>
                       <p:childTnLst>
                         <p:par>
@@ -8075,7 +8075,7 @@
                                   <p:strVal val="visible"/>
                                 </p:to>
                               </p:set>
-                              <p:animEffect transition="in" filter="fly" prLst="dir=l">
+                              <p:animEffect transition="in" filter="fly(l)" prLst="dir=l">
                                 <p:cBhvr>
                                   <p:cTn id="6" dur="500"/>
                                   <p:tgtEl>
@@ -8092,7 +8092,7 @@
                   <p:par>
                     <p:cTn id="7" fill="hold">
                       <p:stCondLst>
-                        <p:cond delay="0"/>
+                        <p:cond delay="indefinite"/>
                       </p:stCondLst>
                       <p:childTnLst>
                         <p:par>
@@ -8115,7 +8115,7 @@
                                   <p:strVal val="visible"/>
                                 </p:to>
                               </p:set>
-                              <p:animEffect transition="in" filter="fly" prLst="dir=l">
+                              <p:animEffect transition="in" filter="fly(l)" prLst="dir=l">
                                 <p:cBhvr>
                                   <p:cTn id="10" dur="500"/>
                                   <p:tgtEl>
@@ -8137,8 +8137,8 @@
       </p:par>
     </p:tnLst>
     <p:bldLst>
-      <p:bldP spid="4" grpId="0"/>
-      <p:bldP spid="6" grpId="0"/>
+      <p:bldP spid="4" grpId="0" build="allAtOnce"/>
+      <p:bldP spid="6" grpId="0" build="allAtOnce"/>
     </p:bldLst>
   </p:timing>
 </p:sld>
@@ -8449,7 +8449,7 @@
                   <p:par>
                     <p:cTn id="3" fill="hold">
                       <p:stCondLst>
-                        <p:cond delay="0"/>
+                        <p:cond delay="indefinite"/>
                       </p:stCondLst>
                       <p:childTnLst>
                         <p:par>
@@ -8472,7 +8472,7 @@
                                   <p:strVal val="visible"/>
                                 </p:to>
                               </p:set>
-                              <p:animEffect transition="in" filter="fly" prLst="dir=l">
+                              <p:animEffect transition="in" filter="fly(l)" prLst="dir=l">
                                 <p:cBhvr>
                                   <p:cTn id="6" dur="500"/>
                                   <p:tgtEl>
@@ -8489,7 +8489,7 @@
                   <p:par>
                     <p:cTn id="7" fill="hold">
                       <p:stCondLst>
-                        <p:cond delay="0"/>
+                        <p:cond delay="indefinite"/>
                       </p:stCondLst>
                       <p:childTnLst>
                         <p:par>
@@ -8512,7 +8512,7 @@
                                   <p:strVal val="visible"/>
                                 </p:to>
                               </p:set>
-                              <p:animEffect transition="in" filter="fly" prLst="dir=l">
+                              <p:animEffect transition="in" filter="fly(l)" prLst="dir=l">
                                 <p:cBhvr>
                                   <p:cTn id="10" dur="500"/>
                                   <p:tgtEl>
@@ -8534,8 +8534,8 @@
       </p:par>
     </p:tnLst>
     <p:bldLst>
-      <p:bldP spid="4" grpId="0"/>
-      <p:bldP spid="6" grpId="0"/>
+      <p:bldP spid="4" grpId="0" build="allAtOnce"/>
+      <p:bldP spid="6" grpId="0" build="allAtOnce"/>
     </p:bldLst>
   </p:timing>
 </p:sld>
@@ -8845,7 +8845,7 @@
                   <p:par>
                     <p:cTn id="3" fill="hold">
                       <p:stCondLst>
-                        <p:cond delay="0"/>
+                        <p:cond delay="indefinite"/>
                       </p:stCondLst>
                       <p:childTnLst>
                         <p:par>
@@ -8868,7 +8868,7 @@
                                   <p:strVal val="visible"/>
                                 </p:to>
                               </p:set>
-                              <p:animEffect transition="in" filter="fly" prLst="dir=l">
+                              <p:animEffect transition="in" filter="fly(l)" prLst="dir=l">
                                 <p:cBhvr>
                                   <p:cTn id="6" dur="500"/>
                                   <p:tgtEl>
@@ -8885,7 +8885,7 @@
                   <p:par>
                     <p:cTn id="7" fill="hold">
                       <p:stCondLst>
-                        <p:cond delay="0"/>
+                        <p:cond delay="indefinite"/>
                       </p:stCondLst>
                       <p:childTnLst>
                         <p:par>
@@ -8908,7 +8908,7 @@
                                   <p:strVal val="visible"/>
                                 </p:to>
                               </p:set>
-                              <p:animEffect transition="in" filter="fly" prLst="dir=l">
+                              <p:animEffect transition="in" filter="fly(l)" prLst="dir=l">
                                 <p:cBhvr>
                                   <p:cTn id="10" dur="500"/>
                                   <p:tgtEl>
@@ -8930,8 +8930,8 @@
       </p:par>
     </p:tnLst>
     <p:bldLst>
-      <p:bldP spid="4" grpId="0"/>
-      <p:bldP spid="6" grpId="0"/>
+      <p:bldP spid="4" grpId="0" build="allAtOnce"/>
+      <p:bldP spid="6" grpId="0" build="allAtOnce"/>
     </p:bldLst>
   </p:timing>
 </p:sld>
@@ -9240,7 +9240,7 @@
                   <p:par>
                     <p:cTn id="3" fill="hold">
                       <p:stCondLst>
-                        <p:cond delay="0"/>
+                        <p:cond delay="indefinite"/>
                       </p:stCondLst>
                       <p:childTnLst>
                         <p:par>
@@ -9263,7 +9263,7 @@
                                   <p:strVal val="visible"/>
                                 </p:to>
                               </p:set>
-                              <p:animEffect transition="in" filter="fly" prLst="dir=l">
+                              <p:animEffect transition="in" filter="fly(l)" prLst="dir=l">
                                 <p:cBhvr>
                                   <p:cTn id="6" dur="500"/>
                                   <p:tgtEl>
@@ -9280,7 +9280,7 @@
                   <p:par>
                     <p:cTn id="7" fill="hold">
                       <p:stCondLst>
-                        <p:cond delay="0"/>
+                        <p:cond delay="indefinite"/>
                       </p:stCondLst>
                       <p:childTnLst>
                         <p:par>
@@ -9303,7 +9303,7 @@
                                   <p:strVal val="visible"/>
                                 </p:to>
                               </p:set>
-                              <p:animEffect transition="in" filter="fly" prLst="dir=l">
+                              <p:animEffect transition="in" filter="fly(l)" prLst="dir=l">
                                 <p:cBhvr>
                                   <p:cTn id="10" dur="500"/>
                                   <p:tgtEl>
@@ -9325,8 +9325,8 @@
       </p:par>
     </p:tnLst>
     <p:bldLst>
-      <p:bldP spid="4" grpId="0"/>
-      <p:bldP spid="6" grpId="0"/>
+      <p:bldP spid="4" grpId="0" build="allAtOnce"/>
+      <p:bldP spid="6" grpId="0" build="allAtOnce"/>
     </p:bldLst>
   </p:timing>
 </p:sld>
@@ -9637,7 +9637,7 @@
                   <p:par>
                     <p:cTn id="3" fill="hold">
                       <p:stCondLst>
-                        <p:cond delay="0"/>
+                        <p:cond delay="indefinite"/>
                       </p:stCondLst>
                       <p:childTnLst>
                         <p:par>
@@ -9660,7 +9660,7 @@
                                   <p:strVal val="visible"/>
                                 </p:to>
                               </p:set>
-                              <p:animEffect transition="in" filter="fly" prLst="dir=l">
+                              <p:animEffect transition="in" filter="fly(l)" prLst="dir=l">
                                 <p:cBhvr>
                                   <p:cTn id="6" dur="500"/>
                                   <p:tgtEl>
@@ -9677,7 +9677,7 @@
                   <p:par>
                     <p:cTn id="7" fill="hold">
                       <p:stCondLst>
-                        <p:cond delay="0"/>
+                        <p:cond delay="indefinite"/>
                       </p:stCondLst>
                       <p:childTnLst>
                         <p:par>
@@ -9700,7 +9700,7 @@
                                   <p:strVal val="visible"/>
                                 </p:to>
                               </p:set>
-                              <p:animEffect transition="in" filter="fly" prLst="dir=l">
+                              <p:animEffect transition="in" filter="fly(l)" prLst="dir=l">
                                 <p:cBhvr>
                                   <p:cTn id="10" dur="500"/>
                                   <p:tgtEl>
@@ -9722,8 +9722,8 @@
       </p:par>
     </p:tnLst>
     <p:bldLst>
-      <p:bldP spid="4" grpId="0"/>
-      <p:bldP spid="6" grpId="0"/>
+      <p:bldP spid="4" grpId="0" build="allAtOnce"/>
+      <p:bldP spid="6" grpId="0" build="allAtOnce"/>
     </p:bldLst>
   </p:timing>
 </p:sld>
@@ -10033,7 +10033,7 @@
                   <p:par>
                     <p:cTn id="3" fill="hold">
                       <p:stCondLst>
-                        <p:cond delay="0"/>
+                        <p:cond delay="indefinite"/>
                       </p:stCondLst>
                       <p:childTnLst>
                         <p:par>
@@ -10056,7 +10056,7 @@
                                   <p:strVal val="visible"/>
                                 </p:to>
                               </p:set>
-                              <p:animEffect transition="in" filter="fly" prLst="dir=l">
+                              <p:animEffect transition="in" filter="fly(l)" prLst="dir=l">
                                 <p:cBhvr>
                                   <p:cTn id="6" dur="500"/>
                                   <p:tgtEl>
@@ -10073,7 +10073,7 @@
                   <p:par>
                     <p:cTn id="7" fill="hold">
                       <p:stCondLst>
-                        <p:cond delay="0"/>
+                        <p:cond delay="indefinite"/>
                       </p:stCondLst>
                       <p:childTnLst>
                         <p:par>
@@ -10096,7 +10096,7 @@
                                   <p:strVal val="visible"/>
                                 </p:to>
                               </p:set>
-                              <p:animEffect transition="in" filter="fly" prLst="dir=l">
+                              <p:animEffect transition="in" filter="fly(l)" prLst="dir=l">
                                 <p:cBhvr>
                                   <p:cTn id="10" dur="500"/>
                                   <p:tgtEl>
@@ -10118,8 +10118,8 @@
       </p:par>
     </p:tnLst>
     <p:bldLst>
-      <p:bldP spid="4" grpId="0"/>
-      <p:bldP spid="6" grpId="0"/>
+      <p:bldP spid="4" grpId="0" build="allAtOnce"/>
+      <p:bldP spid="6" grpId="0" build="allAtOnce"/>
     </p:bldLst>
   </p:timing>
 </p:sld>
@@ -10470,7 +10470,7 @@
                   <p:par>
                     <p:cTn id="3" fill="hold">
                       <p:stCondLst>
-                        <p:cond delay="0"/>
+                        <p:cond delay="indefinite"/>
                       </p:stCondLst>
                       <p:childTnLst>
                         <p:par>
@@ -10493,7 +10493,7 @@
                                   <p:strVal val="visible"/>
                                 </p:to>
                               </p:set>
-                              <p:animEffect transition="in" filter="fly" prLst="dir=l">
+                              <p:animEffect transition="in" filter="fly(l)" prLst="dir=l">
                                 <p:cBhvr>
                                   <p:cTn id="6" dur="500"/>
                                   <p:tgtEl>
@@ -10515,7 +10515,7 @@
       </p:par>
     </p:tnLst>
     <p:bldLst>
-      <p:bldP spid="3" grpId="0"/>
+      <p:bldP spid="3" grpId="0" build="allAtOnce"/>
     </p:bldLst>
   </p:timing>
 </p:sld>
@@ -10839,7 +10839,7 @@
                   <p:par>
                     <p:cTn id="3" fill="hold">
                       <p:stCondLst>
-                        <p:cond delay="0"/>
+                        <p:cond delay="indefinite"/>
                       </p:stCondLst>
                       <p:childTnLst>
                         <p:par>
@@ -10862,7 +10862,7 @@
                                   <p:strVal val="visible"/>
                                 </p:to>
                               </p:set>
-                              <p:animEffect transition="in" filter="fly" prLst="dir=l">
+                              <p:animEffect transition="in" filter="fly(l)" prLst="dir=l">
                                 <p:cBhvr>
                                   <p:cTn id="6" dur="500"/>
                                   <p:tgtEl>
@@ -10884,7 +10884,7 @@
       </p:par>
     </p:tnLst>
     <p:bldLst>
-      <p:bldP spid="3" grpId="0"/>
+      <p:bldP spid="3" grpId="0" build="allAtOnce"/>
     </p:bldLst>
   </p:timing>
 </p:sld>
@@ -11217,7 +11217,7 @@
                   <p:par>
                     <p:cTn id="3" fill="hold">
                       <p:stCondLst>
-                        <p:cond delay="0"/>
+                        <p:cond delay="indefinite"/>
                       </p:stCondLst>
                       <p:childTnLst>
                         <p:par>
@@ -11240,7 +11240,7 @@
                                   <p:strVal val="visible"/>
                                 </p:to>
                               </p:set>
-                              <p:animEffect transition="in" filter="fly" prLst="dir=l">
+                              <p:animEffect transition="in" filter="fly(l)" prLst="dir=l">
                                 <p:cBhvr>
                                   <p:cTn id="6" dur="500"/>
                                   <p:tgtEl>
@@ -11262,7 +11262,7 @@
       </p:par>
     </p:tnLst>
     <p:bldLst>
-      <p:bldP spid="3" grpId="0"/>
+      <p:bldP spid="3" grpId="0" build="allAtOnce"/>
     </p:bldLst>
   </p:timing>
 </p:sld>
@@ -11656,7 +11656,7 @@
                   <p:par>
                     <p:cTn id="3" fill="hold">
                       <p:stCondLst>
-                        <p:cond delay="0"/>
+                        <p:cond delay="indefinite"/>
                       </p:stCondLst>
                       <p:childTnLst>
                         <p:par>
@@ -11679,7 +11679,7 @@
                                   <p:strVal val="visible"/>
                                 </p:to>
                               </p:set>
-                              <p:animEffect transition="in" filter="fly" prLst="dir=l">
+                              <p:animEffect transition="in" filter="fly(l)" prLst="dir=l">
                                 <p:cBhvr>
                                   <p:cTn id="6" dur="500"/>
                                   <p:tgtEl>
@@ -11696,7 +11696,7 @@
                   <p:par>
                     <p:cTn id="7" fill="hold">
                       <p:stCondLst>
-                        <p:cond delay="0"/>
+                        <p:cond delay="indefinite"/>
                       </p:stCondLst>
                       <p:childTnLst>
                         <p:par>
@@ -11719,7 +11719,7 @@
                                   <p:strVal val="visible"/>
                                 </p:to>
                               </p:set>
-                              <p:animEffect transition="in" filter="fly" prLst="dir=l">
+                              <p:animEffect transition="in" filter="fly(l)" prLst="dir=l">
                                 <p:cBhvr>
                                   <p:cTn id="10" dur="500"/>
                                   <p:tgtEl>
@@ -11741,8 +11741,8 @@
       </p:par>
     </p:tnLst>
     <p:bldLst>
-      <p:bldP spid="4" grpId="0"/>
-      <p:bldP spid="6" grpId="0"/>
+      <p:bldP spid="4" grpId="0" build="allAtOnce"/>
+      <p:bldP spid="6" grpId="0" build="allAtOnce"/>
     </p:bldLst>
   </p:timing>
 </p:sld>
@@ -12159,7 +12159,7 @@
                   <p:par>
                     <p:cTn id="3" fill="hold">
                       <p:stCondLst>
-                        <p:cond delay="0"/>
+                        <p:cond delay="indefinite"/>
                       </p:stCondLst>
                       <p:childTnLst>
                         <p:par>
@@ -12182,7 +12182,7 @@
                                   <p:strVal val="visible"/>
                                 </p:to>
                               </p:set>
-                              <p:animEffect transition="in" filter="fly" prLst="dir=l">
+                              <p:animEffect transition="in" filter="fly(l)" prLst="dir=l">
                                 <p:cBhvr>
                                   <p:cTn id="6" dur="500"/>
                                   <p:tgtEl>
@@ -12204,7 +12204,7 @@
       </p:par>
     </p:tnLst>
     <p:bldLst>
-      <p:bldP spid="3" grpId="0"/>
+      <p:bldP spid="3" grpId="0" build="allAtOnce"/>
     </p:bldLst>
   </p:timing>
 </p:sld>
@@ -12619,7 +12619,7 @@
                   <p:par>
                     <p:cTn id="3" fill="hold">
                       <p:stCondLst>
-                        <p:cond delay="0"/>
+                        <p:cond delay="indefinite"/>
                       </p:stCondLst>
                       <p:childTnLst>
                         <p:par>
@@ -12642,7 +12642,7 @@
                                   <p:strVal val="visible"/>
                                 </p:to>
                               </p:set>
-                              <p:animEffect transition="in" filter="fly" prLst="dir=l">
+                              <p:animEffect transition="in" filter="fly(l)" prLst="dir=l">
                                 <p:cBhvr>
                                   <p:cTn id="6" dur="500"/>
                                   <p:tgtEl>
@@ -12659,7 +12659,7 @@
                   <p:par>
                     <p:cTn id="7" fill="hold">
                       <p:stCondLst>
-                        <p:cond delay="0"/>
+                        <p:cond delay="indefinite"/>
                       </p:stCondLst>
                       <p:childTnLst>
                         <p:par>
@@ -12682,7 +12682,7 @@
                                   <p:strVal val="visible"/>
                                 </p:to>
                               </p:set>
-                              <p:animEffect transition="in" filter="fly" prLst="dir=l">
+                              <p:animEffect transition="in" filter="fly(l)" prLst="dir=l">
                                 <p:cBhvr>
                                   <p:cTn id="10" dur="500"/>
                                   <p:tgtEl>
@@ -12704,8 +12704,8 @@
       </p:par>
     </p:tnLst>
     <p:bldLst>
-      <p:bldP spid="3" grpId="0"/>
-      <p:bldP spid="4" grpId="0"/>
+      <p:bldP spid="3" grpId="0" build="allAtOnce"/>
+      <p:bldP spid="4" grpId="0" build="allAtOnce"/>
     </p:bldLst>
   </p:timing>
 </p:sld>
@@ -13031,7 +13031,7 @@
                   <p:par>
                     <p:cTn id="3" fill="hold">
                       <p:stCondLst>
-                        <p:cond delay="0"/>
+                        <p:cond delay="indefinite"/>
                       </p:stCondLst>
                       <p:childTnLst>
                         <p:par>
@@ -13054,7 +13054,7 @@
                                   <p:strVal val="visible"/>
                                 </p:to>
                               </p:set>
-                              <p:animEffect transition="in" filter="fly" prLst="dir=l">
+                              <p:animEffect transition="in" filter="fly(l)" prLst="dir=l">
                                 <p:cBhvr>
                                   <p:cTn id="6" dur="500"/>
                                   <p:tgtEl>
@@ -13076,7 +13076,7 @@
       </p:par>
     </p:tnLst>
     <p:bldLst>
-      <p:bldP spid="3" grpId="0"/>
+      <p:bldP spid="3" grpId="0" build="allAtOnce"/>
     </p:bldLst>
   </p:timing>
 </p:sld>
@@ -13386,7 +13386,7 @@
                   <p:par>
                     <p:cTn id="3" fill="hold">
                       <p:stCondLst>
-                        <p:cond delay="0"/>
+                        <p:cond delay="indefinite"/>
                       </p:stCondLst>
                       <p:childTnLst>
                         <p:par>
@@ -13409,7 +13409,7 @@
                                   <p:strVal val="visible"/>
                                 </p:to>
                               </p:set>
-                              <p:animEffect transition="in" filter="fly" prLst="dir=l">
+                              <p:animEffect transition="in" filter="fly(l)" prLst="dir=l">
                                 <p:cBhvr>
                                   <p:cTn id="6" dur="500"/>
                                   <p:tgtEl>
@@ -13426,7 +13426,7 @@
                   <p:par>
                     <p:cTn id="7" fill="hold">
                       <p:stCondLst>
-                        <p:cond delay="0"/>
+                        <p:cond delay="indefinite"/>
                       </p:stCondLst>
                       <p:childTnLst>
                         <p:par>
@@ -13449,7 +13449,7 @@
                                   <p:strVal val="visible"/>
                                 </p:to>
                               </p:set>
-                              <p:animEffect transition="in" filter="fly" prLst="dir=l">
+                              <p:animEffect transition="in" filter="fly(l)" prLst="dir=l">
                                 <p:cBhvr>
                                   <p:cTn id="10" dur="500"/>
                                   <p:tgtEl>
@@ -13471,8 +13471,8 @@
       </p:par>
     </p:tnLst>
     <p:bldLst>
-      <p:bldP spid="4" grpId="0"/>
-      <p:bldP spid="6" grpId="0"/>
+      <p:bldP spid="4" grpId="0" build="allAtOnce"/>
+      <p:bldP spid="6" grpId="0" build="allAtOnce"/>
     </p:bldLst>
   </p:timing>
 </p:sld>
@@ -13713,7 +13713,7 @@
                   <p:par>
                     <p:cTn id="3" fill="hold">
                       <p:stCondLst>
-                        <p:cond delay="0"/>
+                        <p:cond delay="indefinite"/>
                       </p:stCondLst>
                       <p:childTnLst>
                         <p:par>
@@ -13736,7 +13736,7 @@
                                   <p:strVal val="visible"/>
                                 </p:to>
                               </p:set>
-                              <p:animEffect transition="in" filter="fly" prLst="dir=l">
+                              <p:animEffect transition="in" filter="fly(l)" prLst="dir=l">
                                 <p:cBhvr>
                                   <p:cTn id="6" dur="500"/>
                                   <p:tgtEl>
@@ -13758,7 +13758,7 @@
       </p:par>
     </p:tnLst>
     <p:bldLst>
-      <p:bldP spid="3" grpId="0"/>
+      <p:bldP spid="3" grpId="0" build="allAtOnce"/>
     </p:bldLst>
   </p:timing>
 </p:sld>
@@ -14023,7 +14023,7 @@
                   <p:par>
                     <p:cTn id="3" fill="hold">
                       <p:stCondLst>
-                        <p:cond delay="0"/>
+                        <p:cond delay="indefinite"/>
                       </p:stCondLst>
                       <p:childTnLst>
                         <p:par>
@@ -14046,7 +14046,7 @@
                                   <p:strVal val="visible"/>
                                 </p:to>
                               </p:set>
-                              <p:animEffect transition="in" filter="fly" prLst="dir=l">
+                              <p:animEffect transition="in" filter="fly(l)" prLst="dir=l">
                                 <p:cBhvr>
                                   <p:cTn id="6" dur="500"/>
                                   <p:tgtEl>
@@ -14068,7 +14068,7 @@
       </p:par>
     </p:tnLst>
     <p:bldLst>
-      <p:bldP spid="3" grpId="0"/>
+      <p:bldP spid="3" grpId="0" build="allAtOnce"/>
     </p:bldLst>
   </p:timing>
 </p:sld>
@@ -14383,7 +14383,7 @@
                   <p:par>
                     <p:cTn id="3" fill="hold">
                       <p:stCondLst>
-                        <p:cond delay="0"/>
+                        <p:cond delay="indefinite"/>
                       </p:stCondLst>
                       <p:childTnLst>
                         <p:par>
@@ -14406,7 +14406,7 @@
                                   <p:strVal val="visible"/>
                                 </p:to>
                               </p:set>
-                              <p:animEffect transition="in" filter="fly" prLst="dir=l">
+                              <p:animEffect transition="in" filter="fly(l)" prLst="dir=l">
                                 <p:cBhvr>
                                   <p:cTn id="6" dur="500"/>
                                   <p:tgtEl>
@@ -14428,7 +14428,7 @@
       </p:par>
     </p:tnLst>
     <p:bldLst>
-      <p:bldP spid="3" grpId="0"/>
+      <p:bldP spid="3" grpId="0" build="allAtOnce"/>
     </p:bldLst>
   </p:timing>
 </p:sld>
@@ -14624,7 +14624,7 @@
                   <p:par>
                     <p:cTn id="3" fill="hold">
                       <p:stCondLst>
-                        <p:cond delay="0"/>
+                        <p:cond delay="indefinite"/>
                       </p:stCondLst>
                       <p:childTnLst>
                         <p:par>
@@ -14647,7 +14647,7 @@
                                   <p:strVal val="visible"/>
                                 </p:to>
                               </p:set>
-                              <p:animEffect transition="in" filter="fly" prLst="dir=l">
+                              <p:animEffect transition="in" filter="fly(l)" prLst="dir=l">
                                 <p:cBhvr>
                                   <p:cTn id="6" dur="500"/>
                                   <p:tgtEl>
@@ -14669,7 +14669,7 @@
       </p:par>
     </p:tnLst>
     <p:bldLst>
-      <p:bldP spid="4" grpId="0"/>
+      <p:bldP spid="4" grpId="0" build="allAtOnce"/>
     </p:bldLst>
   </p:timing>
 </p:sld>
@@ -14819,7 +14819,7 @@
                   <p:par>
                     <p:cTn id="3" fill="hold">
                       <p:stCondLst>
-                        <p:cond delay="0"/>
+                        <p:cond delay="indefinite"/>
                       </p:stCondLst>
                       <p:childTnLst>
                         <p:par>
@@ -14842,7 +14842,7 @@
                                   <p:strVal val="visible"/>
                                 </p:to>
                               </p:set>
-                              <p:animEffect transition="in" filter="fly" prLst="dir=l">
+                              <p:animEffect transition="in" filter="fly(l)" prLst="dir=l">
                                 <p:cBhvr>
                                   <p:cTn id="6" dur="500"/>
                                   <p:tgtEl>
@@ -14864,7 +14864,7 @@
       </p:par>
     </p:tnLst>
     <p:bldLst>
-      <p:bldP spid="3" grpId="0"/>
+      <p:bldP spid="3" grpId="0" build="allAtOnce"/>
     </p:bldLst>
   </p:timing>
 </p:sld>
@@ -15175,7 +15175,7 @@
                   <p:par>
                     <p:cTn id="3" fill="hold">
                       <p:stCondLst>
-                        <p:cond delay="0"/>
+                        <p:cond delay="indefinite"/>
                       </p:stCondLst>
                       <p:childTnLst>
                         <p:par>
@@ -15198,7 +15198,7 @@
                                   <p:strVal val="visible"/>
                                 </p:to>
                               </p:set>
-                              <p:animEffect transition="in" filter="fly" prLst="dir=l">
+                              <p:animEffect transition="in" filter="fly(l)" prLst="dir=l">
                                 <p:cBhvr>
                                   <p:cTn id="6" dur="500"/>
                                   <p:tgtEl>
@@ -15215,7 +15215,7 @@
                   <p:par>
                     <p:cTn id="7" fill="hold">
                       <p:stCondLst>
-                        <p:cond delay="0"/>
+                        <p:cond delay="indefinite"/>
                       </p:stCondLst>
                       <p:childTnLst>
                         <p:par>
@@ -15238,7 +15238,7 @@
                                   <p:strVal val="visible"/>
                                 </p:to>
                               </p:set>
-                              <p:animEffect transition="in" filter="fly" prLst="dir=l">
+                              <p:animEffect transition="in" filter="fly(l)" prLst="dir=l">
                                 <p:cBhvr>
                                   <p:cTn id="10" dur="500"/>
                                   <p:tgtEl>
@@ -15260,8 +15260,8 @@
       </p:par>
     </p:tnLst>
     <p:bldLst>
-      <p:bldP spid="4" grpId="0"/>
-      <p:bldP spid="6" grpId="0"/>
+      <p:bldP spid="4" grpId="0" build="allAtOnce"/>
+      <p:bldP spid="6" grpId="0" build="allAtOnce"/>
     </p:bldLst>
   </p:timing>
 </p:sld>
@@ -15574,7 +15574,7 @@
                   <p:par>
                     <p:cTn id="3" fill="hold">
                       <p:stCondLst>
-                        <p:cond delay="0"/>
+                        <p:cond delay="indefinite"/>
                       </p:stCondLst>
                       <p:childTnLst>
                         <p:par>
@@ -15597,7 +15597,7 @@
                                   <p:strVal val="visible"/>
                                 </p:to>
                               </p:set>
-                              <p:animEffect transition="in" filter="fly" prLst="dir=l">
+                              <p:animEffect transition="in" filter="fly(l)" prLst="dir=l">
                                 <p:cBhvr>
                                   <p:cTn id="6" dur="500"/>
                                   <p:tgtEl>
@@ -15614,7 +15614,7 @@
                   <p:par>
                     <p:cTn id="7" fill="hold">
                       <p:stCondLst>
-                        <p:cond delay="0"/>
+                        <p:cond delay="indefinite"/>
                       </p:stCondLst>
                       <p:childTnLst>
                         <p:par>
@@ -15637,7 +15637,7 @@
                                   <p:strVal val="visible"/>
                                 </p:to>
                               </p:set>
-                              <p:animEffect transition="in" filter="fly" prLst="dir=l">
+                              <p:animEffect transition="in" filter="fly(l)" prLst="dir=l">
                                 <p:cBhvr>
                                   <p:cTn id="10" dur="500"/>
                                   <p:tgtEl>
@@ -15659,8 +15659,8 @@
       </p:par>
     </p:tnLst>
     <p:bldLst>
-      <p:bldP spid="4" grpId="0"/>
-      <p:bldP spid="6" grpId="0"/>
+      <p:bldP spid="4" grpId="0" build="allAtOnce"/>
+      <p:bldP spid="6" grpId="0" build="allAtOnce"/>
     </p:bldLst>
   </p:timing>
 </p:sld>
@@ -15857,7 +15857,7 @@
                   <p:par>
                     <p:cTn id="3" fill="hold">
                       <p:stCondLst>
-                        <p:cond delay="0"/>
+                        <p:cond delay="indefinite"/>
                       </p:stCondLst>
                       <p:childTnLst>
                         <p:par>
@@ -15880,7 +15880,7 @@
                                   <p:strVal val="visible"/>
                                 </p:to>
                               </p:set>
-                              <p:animEffect transition="in" filter="fly" prLst="dir=l">
+                              <p:animEffect transition="in" filter="fly(l)" prLst="dir=l">
                                 <p:cBhvr>
                                   <p:cTn id="6" dur="500"/>
                                   <p:tgtEl>
@@ -15902,7 +15902,7 @@
       </p:par>
     </p:tnLst>
     <p:bldLst>
-      <p:bldP spid="4" grpId="0"/>
+      <p:bldP spid="4" grpId="0" build="allAtOnce"/>
     </p:bldLst>
   </p:timing>
 </p:sld>
@@ -16049,7 +16049,7 @@
                   <p:par>
                     <p:cTn id="3" fill="hold">
                       <p:stCondLst>
-                        <p:cond delay="0"/>
+                        <p:cond delay="indefinite"/>
                       </p:stCondLst>
                       <p:childTnLst>
                         <p:par>
@@ -16072,7 +16072,7 @@
                                   <p:strVal val="visible"/>
                                 </p:to>
                               </p:set>
-                              <p:animEffect transition="in" filter="fly" prLst="dir=l">
+                              <p:animEffect transition="in" filter="fly(l)" prLst="dir=l">
                                 <p:cBhvr>
                                   <p:cTn id="6" dur="500"/>
                                   <p:tgtEl>
@@ -16094,7 +16094,7 @@
       </p:par>
     </p:tnLst>
     <p:bldLst>
-      <p:bldP spid="3" grpId="0"/>
+      <p:bldP spid="3" grpId="0" build="allAtOnce"/>
     </p:bldLst>
   </p:timing>
 </p:sld>
@@ -16293,7 +16293,7 @@
                   <p:par>
                     <p:cTn id="3" fill="hold">
                       <p:stCondLst>
-                        <p:cond delay="0"/>
+                        <p:cond delay="indefinite"/>
                       </p:stCondLst>
                       <p:childTnLst>
                         <p:par>
@@ -16316,7 +16316,7 @@
                                   <p:strVal val="visible"/>
                                 </p:to>
                               </p:set>
-                              <p:animEffect transition="in" filter="fly" prLst="dir=l">
+                              <p:animEffect transition="in" filter="fly(l)" prLst="dir=l">
                                 <p:cBhvr>
                                   <p:cTn id="6" dur="500"/>
                                   <p:tgtEl>
@@ -16338,7 +16338,7 @@
       </p:par>
     </p:tnLst>
     <p:bldLst>
-      <p:bldP spid="4" grpId="0"/>
+      <p:bldP spid="4" grpId="0" build="allAtOnce"/>
     </p:bldLst>
   </p:timing>
 </p:sld>
@@ -16488,7 +16488,7 @@
                   <p:par>
                     <p:cTn id="3" fill="hold">
                       <p:stCondLst>
-                        <p:cond delay="0"/>
+                        <p:cond delay="indefinite"/>
                       </p:stCondLst>
                       <p:childTnLst>
                         <p:par>
@@ -16511,7 +16511,7 @@
                                   <p:strVal val="visible"/>
                                 </p:to>
                               </p:set>
-                              <p:animEffect transition="in" filter="fly" prLst="dir=l">
+                              <p:animEffect transition="in" filter="fly(l)" prLst="dir=l">
                                 <p:cBhvr>
                                   <p:cTn id="6" dur="500"/>
                                   <p:tgtEl>
@@ -16533,7 +16533,7 @@
       </p:par>
     </p:tnLst>
     <p:bldLst>
-      <p:bldP spid="3" grpId="0"/>
+      <p:bldP spid="3" grpId="0" build="allAtOnce"/>
     </p:bldLst>
   </p:timing>
 </p:sld>
@@ -16799,7 +16799,7 @@
                   <p:par>
                     <p:cTn id="3" fill="hold">
                       <p:stCondLst>
-                        <p:cond delay="0"/>
+                        <p:cond delay="indefinite"/>
                       </p:stCondLst>
                       <p:childTnLst>
                         <p:par>
@@ -16822,7 +16822,7 @@
                                   <p:strVal val="visible"/>
                                 </p:to>
                               </p:set>
-                              <p:animEffect transition="in" filter="fly" prLst="dir=l">
+                              <p:animEffect transition="in" filter="fly(l)" prLst="dir=l">
                                 <p:cBhvr>
                                   <p:cTn id="6" dur="500"/>
                                   <p:tgtEl>
@@ -16844,7 +16844,7 @@
       </p:par>
     </p:tnLst>
     <p:bldLst>
-      <p:bldP spid="3" grpId="0"/>
+      <p:bldP spid="3" grpId="0" build="allAtOnce"/>
     </p:bldLst>
   </p:timing>
 </p:sld>
@@ -16930,7 +16930,7 @@
                   <p:par>
                     <p:cTn id="3" fill="hold">
                       <p:stCondLst>
-                        <p:cond delay="0"/>
+                        <p:cond delay="indefinite"/>
                       </p:stCondLst>
                       <p:childTnLst>
                         <p:par>
@@ -16953,7 +16953,7 @@
                                   <p:strVal val="visible"/>
                                 </p:to>
                               </p:set>
-                              <p:animEffect transition="in" filter="fly" prLst="dir=l">
+                              <p:animEffect transition="in" filter="fly(l)" prLst="dir=l">
                                 <p:cBhvr>
                                   <p:cTn id="6" dur="500"/>
                                   <p:tgtEl>
@@ -16975,7 +16975,7 @@
       </p:par>
     </p:tnLst>
     <p:bldLst>
-      <p:bldP spid="2" grpId="0"/>
+      <p:bldP spid="2" grpId="0" build="allAtOnce"/>
     </p:bldLst>
   </p:timing>
 </p:sld>
@@ -17126,7 +17126,7 @@
                   <p:par>
                     <p:cTn id="3" fill="hold">
                       <p:stCondLst>
-                        <p:cond delay="0"/>
+                        <p:cond delay="indefinite"/>
                       </p:stCondLst>
                       <p:childTnLst>
                         <p:par>
@@ -17149,7 +17149,7 @@
                                   <p:strVal val="visible"/>
                                 </p:to>
                               </p:set>
-                              <p:animEffect transition="in" filter="fly" prLst="dir=l">
+                              <p:animEffect transition="in" filter="fly(l)" prLst="dir=l">
                                 <p:cBhvr>
                                   <p:cTn id="6" dur="500"/>
                                   <p:tgtEl>
@@ -17171,7 +17171,7 @@
       </p:par>
     </p:tnLst>
     <p:bldLst>
-      <p:bldP spid="3" grpId="0"/>
+      <p:bldP spid="3" grpId="0" build="allAtOnce"/>
     </p:bldLst>
   </p:timing>
 </p:sld>
@@ -17731,7 +17731,7 @@
                   <p:par>
                     <p:cTn id="3" fill="hold">
                       <p:stCondLst>
-                        <p:cond delay="0"/>
+                        <p:cond delay="indefinite"/>
                       </p:stCondLst>
                       <p:childTnLst>
                         <p:par>
@@ -17754,7 +17754,7 @@
                                   <p:strVal val="visible"/>
                                 </p:to>
                               </p:set>
-                              <p:animEffect transition="in" filter="fly" prLst="dir=l">
+                              <p:animEffect transition="in" filter="fly(l)" prLst="dir=l">
                                 <p:cBhvr>
                                   <p:cTn id="6" dur="500"/>
                                   <p:tgtEl>
@@ -17776,7 +17776,7 @@
       </p:par>
     </p:tnLst>
     <p:bldLst>
-      <p:bldP spid="3" grpId="0"/>
+      <p:bldP spid="3" grpId="0" build="allAtOnce"/>
     </p:bldLst>
   </p:timing>
 </p:sld>
@@ -18353,7 +18353,7 @@
                   <p:par>
                     <p:cTn id="3" fill="hold">
                       <p:stCondLst>
-                        <p:cond delay="0"/>
+                        <p:cond delay="indefinite"/>
                       </p:stCondLst>
                       <p:childTnLst>
                         <p:par>
@@ -18376,7 +18376,7 @@
                                   <p:strVal val="visible"/>
                                 </p:to>
                               </p:set>
-                              <p:animEffect transition="in" filter="fly" prLst="dir=l">
+                              <p:animEffect transition="in" filter="fly(l)" prLst="dir=l">
                                 <p:cBhvr>
                                   <p:cTn id="6" dur="500"/>
                                   <p:tgtEl>
@@ -18398,7 +18398,7 @@
       </p:par>
     </p:tnLst>
     <p:bldLst>
-      <p:bldP spid="3" grpId="0"/>
+      <p:bldP spid="3" grpId="0" build="allAtOnce"/>
     </p:bldLst>
   </p:timing>
 </p:sld>
@@ -18484,7 +18484,7 @@
                   <p:par>
                     <p:cTn id="3" fill="hold">
                       <p:stCondLst>
-                        <p:cond delay="0"/>
+                        <p:cond delay="indefinite"/>
                       </p:stCondLst>
                       <p:childTnLst>
                         <p:par>
@@ -18507,7 +18507,7 @@
                                   <p:strVal val="visible"/>
                                 </p:to>
                               </p:set>
-                              <p:animEffect transition="in" filter="fly" prLst="dir=l">
+                              <p:animEffect transition="in" filter="fly(l)" prLst="dir=l">
                                 <p:cBhvr>
                                   <p:cTn id="6" dur="500"/>
                                   <p:tgtEl>
@@ -18529,7 +18529,7 @@
       </p:par>
     </p:tnLst>
     <p:bldLst>
-      <p:bldP spid="2" grpId="0"/>
+      <p:bldP spid="2" grpId="0" build="allAtOnce"/>
     </p:bldLst>
   </p:timing>
 </p:sld>
@@ -18759,7 +18759,7 @@
                   <p:par>
                     <p:cTn id="3" fill="hold">
                       <p:stCondLst>
-                        <p:cond delay="0"/>
+                        <p:cond delay="indefinite"/>
                       </p:stCondLst>
                       <p:childTnLst>
                         <p:par>
@@ -18782,7 +18782,7 @@
                                   <p:strVal val="visible"/>
                                 </p:to>
                               </p:set>
-                              <p:animEffect transition="in" filter="fly" prLst="dir=l">
+                              <p:animEffect transition="in" filter="fly(l)" prLst="dir=l">
                                 <p:cBhvr>
                                   <p:cTn id="6" dur="500"/>
                                   <p:tgtEl>
@@ -18804,7 +18804,7 @@
       </p:par>
     </p:tnLst>
     <p:bldLst>
-      <p:bldP spid="3" grpId="0"/>
+      <p:bldP spid="3" grpId="0" build="allAtOnce"/>
     </p:bldLst>
   </p:timing>
 </p:sld>

</xml_diff>